<commit_message>
Add playlist holdout evaluation metrics
</commit_message>
<xml_diff>
--- a/docs/exports/Indian_Music_Intelligence_Platform_v2_Pitch_Deck.pptx
+++ b/docs/exports/Indian_Music_Intelligence_Platform_v2_Pitch_Deck.pptx
@@ -3436,6 +3436,30 @@
               </a:defRPr>
             </a:pPr>
             <a:r>
+              <a:t>playlist holdout hit rate</a:t>
+            </a:r>
+          </a:p>
+          <a:p>
+            <a:pPr>
+              <a:defRPr sz="1900">
+                <a:solidFill>
+                  <a:srgbClr val="1F2937"/>
+                </a:solidFill>
+              </a:defRPr>
+            </a:pPr>
+            <a:r>
+              <a:t>playlist holdout average rank</a:t>
+            </a:r>
+          </a:p>
+          <a:p>
+            <a:pPr>
+              <a:defRPr sz="1900">
+                <a:solidFill>
+                  <a:srgbClr val="1F2937"/>
+                </a:solidFill>
+              </a:defRPr>
+            </a:pPr>
+            <a:r>
               <a:t>TF-IDF</a:t>
             </a:r>
           </a:p>
@@ -3472,7 +3496,7 @@
               </a:defRPr>
             </a:pPr>
             <a:r>
-              <a:t>larger playlist holdout evaluation</a:t>
+              <a:t>larger-scale playlist holdout evaluation</a:t>
             </a:r>
           </a:p>
         </p:txBody>

</xml_diff>